<commit_message>
Tiny updates to the arch diagram slide settings & new screenshot
</commit_message>
<xml_diff>
--- a/BackendFeatures/StatsLeaderboards/Guidance for Game Stats and Leaderboards.pptx
+++ b/BackendFeatures/StatsLeaderboards/Guidance for Game Stats and Leaderboards.pptx
@@ -107,6 +107,11 @@
       </a:defRPr>
     </a:lvl9pPr>
   </p:defaultTextStyle>
+  <p:extLst>
+    <p:ext uri="{EFAFB233-063F-42B5-8137-9DF3F51BA10A}">
+      <p15:sldGuideLst xmlns:p15="http://schemas.microsoft.com/office/powerpoint/2012/main"/>
+    </p:ext>
+  </p:extLst>
 </p:presentation>
 </file>
 
@@ -192,7 +197,7 @@
           <a:p>
             <a:fld id="{D1D9E1E9-3279-B745-A122-F167D0365C34}" type="datetimeFigureOut">
               <a:rPr lang="en-US" smtClean="0"/>
-              <a:t>5/1/26</a:t>
+              <a:t>7/2/26</a:t>
             </a:fld>
             <a:endParaRPr lang="en-US"/>
           </a:p>
@@ -721,7 +726,7 @@
           <a:p>
             <a:fld id="{7F16ACE1-B289-C14A-9467-0E937815EAA0}" type="datetimeFigureOut">
               <a:rPr lang="en-US" smtClean="0"/>
-              <a:t>5/1/26</a:t>
+              <a:t>7/2/26</a:t>
             </a:fld>
             <a:endParaRPr lang="en-US"/>
           </a:p>
@@ -919,7 +924,7 @@
           <a:p>
             <a:fld id="{7F16ACE1-B289-C14A-9467-0E937815EAA0}" type="datetimeFigureOut">
               <a:rPr lang="en-US" smtClean="0"/>
-              <a:t>5/1/26</a:t>
+              <a:t>7/2/26</a:t>
             </a:fld>
             <a:endParaRPr lang="en-US"/>
           </a:p>
@@ -1127,7 +1132,7 @@
           <a:p>
             <a:fld id="{7F16ACE1-B289-C14A-9467-0E937815EAA0}" type="datetimeFigureOut">
               <a:rPr lang="en-US" smtClean="0"/>
-              <a:t>5/1/26</a:t>
+              <a:t>7/2/26</a:t>
             </a:fld>
             <a:endParaRPr lang="en-US"/>
           </a:p>
@@ -1325,7 +1330,7 @@
           <a:p>
             <a:fld id="{7F16ACE1-B289-C14A-9467-0E937815EAA0}" type="datetimeFigureOut">
               <a:rPr lang="en-US" smtClean="0"/>
-              <a:t>5/1/26</a:t>
+              <a:t>7/2/26</a:t>
             </a:fld>
             <a:endParaRPr lang="en-US"/>
           </a:p>
@@ -1600,7 +1605,7 @@
           <a:p>
             <a:fld id="{7F16ACE1-B289-C14A-9467-0E937815EAA0}" type="datetimeFigureOut">
               <a:rPr lang="en-US" smtClean="0"/>
-              <a:t>5/1/26</a:t>
+              <a:t>7/2/26</a:t>
             </a:fld>
             <a:endParaRPr lang="en-US"/>
           </a:p>
@@ -1865,7 +1870,7 @@
           <a:p>
             <a:fld id="{7F16ACE1-B289-C14A-9467-0E937815EAA0}" type="datetimeFigureOut">
               <a:rPr lang="en-US" smtClean="0"/>
-              <a:t>5/1/26</a:t>
+              <a:t>7/2/26</a:t>
             </a:fld>
             <a:endParaRPr lang="en-US"/>
           </a:p>
@@ -2277,7 +2282,7 @@
           <a:p>
             <a:fld id="{7F16ACE1-B289-C14A-9467-0E937815EAA0}" type="datetimeFigureOut">
               <a:rPr lang="en-US" smtClean="0"/>
-              <a:t>5/1/26</a:t>
+              <a:t>7/2/26</a:t>
             </a:fld>
             <a:endParaRPr lang="en-US"/>
           </a:p>
@@ -2418,7 +2423,7 @@
           <a:p>
             <a:fld id="{7F16ACE1-B289-C14A-9467-0E937815EAA0}" type="datetimeFigureOut">
               <a:rPr lang="en-US" smtClean="0"/>
-              <a:t>5/1/26</a:t>
+              <a:t>7/2/26</a:t>
             </a:fld>
             <a:endParaRPr lang="en-US"/>
           </a:p>
@@ -2531,7 +2536,7 @@
           <a:p>
             <a:fld id="{7F16ACE1-B289-C14A-9467-0E937815EAA0}" type="datetimeFigureOut">
               <a:rPr lang="en-US" smtClean="0"/>
-              <a:t>5/1/26</a:t>
+              <a:t>7/2/26</a:t>
             </a:fld>
             <a:endParaRPr lang="en-US"/>
           </a:p>
@@ -2842,7 +2847,7 @@
           <a:p>
             <a:fld id="{7F16ACE1-B289-C14A-9467-0E937815EAA0}" type="datetimeFigureOut">
               <a:rPr lang="en-US" smtClean="0"/>
-              <a:t>5/1/26</a:t>
+              <a:t>7/2/26</a:t>
             </a:fld>
             <a:endParaRPr lang="en-US"/>
           </a:p>
@@ -3130,7 +3135,7 @@
           <a:p>
             <a:fld id="{7F16ACE1-B289-C14A-9467-0E937815EAA0}" type="datetimeFigureOut">
               <a:rPr lang="en-US" smtClean="0"/>
-              <a:t>5/1/26</a:t>
+              <a:t>7/2/26</a:t>
             </a:fld>
             <a:endParaRPr lang="en-US"/>
           </a:p>
@@ -3371,7 +3376,7 @@
           <a:p>
             <a:fld id="{7F16ACE1-B289-C14A-9467-0E937815EAA0}" type="datetimeFigureOut">
               <a:rPr lang="en-US" smtClean="0"/>
-              <a:t>5/1/26</a:t>
+              <a:t>7/2/26</a:t>
             </a:fld>
             <a:endParaRPr lang="en-US"/>
           </a:p>
@@ -3842,7 +3847,7 @@
           <a:lstStyle/>
           <a:p>
             <a:pPr algn="ctr"/>
-            <a:endParaRPr lang="en-US" dirty="0">
+            <a:endParaRPr lang="en-US" noProof="1">
               <a:latin typeface="Arial" panose="020B0604020202020204" pitchFamily="34" charset="0"/>
               <a:cs typeface="Arial" panose="020B0604020202020204" pitchFamily="34" charset="0"/>
             </a:endParaRPr>
@@ -3921,7 +3926,7 @@
           <a:lstStyle/>
           <a:p>
             <a:r>
-              <a:rPr lang="en-US" sz="900" dirty="0">
+              <a:rPr lang="en-US" sz="900" noProof="1">
                 <a:latin typeface="Arial" panose="020B0604020202020204" pitchFamily="34" charset="0"/>
                 <a:ea typeface="Amazon Ember" panose="020B0603020204020204" pitchFamily="34" charset="0"/>
                 <a:cs typeface="Arial" panose="020B0604020202020204" pitchFamily="34" charset="0"/>
@@ -3929,7 +3934,7 @@
               <a:t>Game developer registers a new game with the system via the developer registration API, and receive a new and game-specific </a:t>
             </a:r>
             <a:r>
-              <a:rPr lang="en-US" sz="900" b="1" dirty="0" err="1">
+              <a:rPr lang="en-US" sz="900" b="1" noProof="1">
                 <a:latin typeface="Aptos" panose="020B0004020202020204" pitchFamily="34" charset="0"/>
                 <a:ea typeface="Amazon Ember" panose="020B0603020204020204" pitchFamily="34" charset="0"/>
                 <a:cs typeface="Arial" panose="020B0604020202020204" pitchFamily="34" charset="0"/>
@@ -3937,21 +3942,21 @@
               <a:t>studioAPIKey</a:t>
             </a:r>
             <a:r>
-              <a:rPr lang="en-US" sz="900" dirty="0">
+              <a:rPr lang="en-US" sz="900" noProof="1">
                 <a:latin typeface="Aptos" panose="020B0004020202020204" pitchFamily="34" charset="0"/>
                 <a:ea typeface="Amazon Ember" panose="020B0603020204020204" pitchFamily="34" charset="0"/>
                 <a:cs typeface="Arial" panose="020B0604020202020204" pitchFamily="34" charset="0"/>
               </a:rPr>
               <a:t>.</a:t>
             </a:r>
-            <a:endParaRPr lang="en-US" sz="900" dirty="0">
+            <a:endParaRPr lang="en-US" sz="900" noProof="1">
               <a:latin typeface="Arial" panose="020B0604020202020204" pitchFamily="34" charset="0"/>
               <a:ea typeface="Amazon Ember" panose="020B0603020204020204" pitchFamily="34" charset="0"/>
               <a:cs typeface="Arial" panose="020B0604020202020204" pitchFamily="34" charset="0"/>
             </a:endParaRPr>
           </a:p>
           <a:p>
-            <a:endParaRPr lang="en-US" sz="900" dirty="0">
+            <a:endParaRPr lang="en-US" sz="900" noProof="1">
               <a:latin typeface="Arial" panose="020B0604020202020204" pitchFamily="34" charset="0"/>
               <a:ea typeface="Amazon Ember" panose="020B0603020204020204" pitchFamily="34" charset="0"/>
               <a:cs typeface="Arial" panose="020B0604020202020204" pitchFamily="34" charset="0"/>
@@ -3959,7 +3964,7 @@
           </a:p>
           <a:p>
             <a:r>
-              <a:rPr lang="en-US" sz="900" dirty="0">
+              <a:rPr lang="en-US" sz="900" noProof="1">
                 <a:latin typeface="Arial" panose="020B0604020202020204" pitchFamily="34" charset="0"/>
                 <a:ea typeface="Amazon Ember" panose="020B0603020204020204" pitchFamily="34" charset="0"/>
                 <a:cs typeface="Arial" panose="020B0604020202020204" pitchFamily="34" charset="0"/>
@@ -3968,7 +3973,7 @@
             </a:r>
           </a:p>
           <a:p>
-            <a:endParaRPr lang="en-US" altLang="en-US" sz="900" dirty="0">
+            <a:endParaRPr lang="en-US" sz="900" noProof="1">
               <a:latin typeface="Arial" panose="020B0604020202020204" pitchFamily="34" charset="0"/>
               <a:ea typeface="Amazon Ember" panose="020B0603020204020204" pitchFamily="34" charset="0"/>
               <a:cs typeface="Arial" panose="020B0604020202020204" pitchFamily="34" charset="0"/>
@@ -3976,14 +3981,14 @@
           </a:p>
           <a:p>
             <a:r>
-              <a:rPr lang="en-US" altLang="en-US" sz="900" dirty="0">
+              <a:rPr lang="en-US" sz="900" noProof="1">
                 <a:latin typeface="Arial" panose="020B0604020202020204" pitchFamily="34" charset="0"/>
                 <a:cs typeface="Arial" panose="020B0604020202020204" pitchFamily="34" charset="0"/>
               </a:rPr>
               <a:t>Every request contains the </a:t>
             </a:r>
             <a:r>
-              <a:rPr lang="en-US" sz="900" b="1" dirty="0" err="1">
+              <a:rPr lang="en-US" sz="900" b="1" noProof="1">
                 <a:latin typeface="Aptos" panose="020B0004020202020204" pitchFamily="34" charset="0"/>
                 <a:ea typeface="Amazon Ember" panose="020B0603020204020204" pitchFamily="34" charset="0"/>
                 <a:cs typeface="Arial" panose="020B0604020202020204" pitchFamily="34" charset="0"/>
@@ -3991,35 +3996,35 @@
               <a:t>studioAPIKey</a:t>
             </a:r>
             <a:r>
-              <a:rPr lang="en-US" altLang="en-US" sz="900" dirty="0">
+              <a:rPr lang="en-US" sz="900" noProof="1">
                 <a:latin typeface="Arial" panose="020B0604020202020204" pitchFamily="34" charset="0"/>
                 <a:cs typeface="Arial" panose="020B0604020202020204" pitchFamily="34" charset="0"/>
               </a:rPr>
               <a:t> that is validated by the backend authorizer </a:t>
             </a:r>
             <a:r>
-              <a:rPr lang="en-US" altLang="en-US" sz="900" b="1" dirty="0">
+              <a:rPr lang="en-US" sz="900" b="1" noProof="1">
                 <a:latin typeface="Arial" panose="020B0604020202020204" pitchFamily="34" charset="0"/>
                 <a:cs typeface="Arial" panose="020B0604020202020204" pitchFamily="34" charset="0"/>
               </a:rPr>
               <a:t>AWS Lambda</a:t>
             </a:r>
             <a:r>
-              <a:rPr lang="en-US" altLang="en-US" sz="900" dirty="0">
+              <a:rPr lang="en-US" sz="900" noProof="1">
                 <a:latin typeface="Arial" panose="020B0604020202020204" pitchFamily="34" charset="0"/>
                 <a:cs typeface="Arial" panose="020B0604020202020204" pitchFamily="34" charset="0"/>
               </a:rPr>
               <a:t> function against the key stored in the </a:t>
             </a:r>
             <a:r>
-              <a:rPr lang="en-US" altLang="en-US" sz="900" b="1" dirty="0">
+              <a:rPr lang="en-US" sz="900" b="1" noProof="1">
                 <a:latin typeface="Arial" panose="020B0604020202020204" pitchFamily="34" charset="0"/>
                 <a:cs typeface="Arial" panose="020B0604020202020204" pitchFamily="34" charset="0"/>
               </a:rPr>
               <a:t>AWS Systems Manager Parameter Store</a:t>
             </a:r>
             <a:r>
-              <a:rPr lang="en-US" altLang="en-US" sz="900" dirty="0">
+              <a:rPr lang="en-US" sz="900" noProof="1">
                 <a:latin typeface="Arial" panose="020B0604020202020204" pitchFamily="34" charset="0"/>
                 <a:cs typeface="Arial" panose="020B0604020202020204" pitchFamily="34" charset="0"/>
               </a:rPr>
@@ -4027,7 +4032,7 @@
             </a:r>
           </a:p>
           <a:p>
-            <a:endParaRPr lang="en-US" sz="900" dirty="0">
+            <a:endParaRPr lang="en-US" sz="900" noProof="1">
               <a:latin typeface="Arial" panose="020B0604020202020204" pitchFamily="34" charset="0"/>
               <a:ea typeface="Amazon Ember" panose="020B0603020204020204" pitchFamily="34" charset="0"/>
               <a:cs typeface="Arial" panose="020B0604020202020204" pitchFamily="34" charset="0"/>
@@ -4040,7 +4045,7 @@
               </a:spcAft>
             </a:pPr>
             <a:r>
-              <a:rPr lang="en-US" sz="900" dirty="0">
+              <a:rPr lang="en-US" sz="900" noProof="1">
                 <a:latin typeface="Arial" panose="020B0604020202020204" pitchFamily="34" charset="0"/>
                 <a:ea typeface="Amazon Ember" panose="020B0603020204020204" pitchFamily="34" charset="0"/>
                 <a:cs typeface="Arial" panose="020B0604020202020204" pitchFamily="34" charset="0"/>
@@ -4055,7 +4060,7 @@
               </a:spcAft>
             </a:pPr>
             <a:r>
-              <a:rPr lang="en-US" sz="900" dirty="0">
+              <a:rPr lang="en-US" sz="900" noProof="1">
                 <a:latin typeface="Arial" panose="020B0604020202020204" pitchFamily="34" charset="0"/>
                 <a:ea typeface="Amazon Ember" panose="020B0603020204020204" pitchFamily="34" charset="0"/>
                 <a:cs typeface="Arial" panose="020B0604020202020204" pitchFamily="34" charset="0"/>
@@ -4063,7 +4068,7 @@
               <a:t>The function then stores/updates the data in the </a:t>
             </a:r>
             <a:r>
-              <a:rPr lang="en-US" sz="900" b="1" dirty="0">
+              <a:rPr lang="en-US" sz="900" b="1" noProof="1">
                 <a:latin typeface="Arial" panose="020B0604020202020204" pitchFamily="34" charset="0"/>
                 <a:ea typeface="Amazon Ember" panose="020B0603020204020204" pitchFamily="34" charset="0"/>
                 <a:cs typeface="Arial" panose="020B0604020202020204" pitchFamily="34" charset="0"/>
@@ -4071,7 +4076,7 @@
               <a:t>Amazon DynamoDB</a:t>
             </a:r>
             <a:r>
-              <a:rPr lang="en-US" sz="900" dirty="0">
+              <a:rPr lang="en-US" sz="900" noProof="1">
                 <a:latin typeface="Arial" panose="020B0604020202020204" pitchFamily="34" charset="0"/>
                 <a:ea typeface="Amazon Ember" panose="020B0603020204020204" pitchFamily="34" charset="0"/>
                 <a:cs typeface="Arial" panose="020B0604020202020204" pitchFamily="34" charset="0"/>
@@ -4086,7 +4091,7 @@
               </a:spcAft>
             </a:pPr>
             <a:r>
-              <a:rPr lang="en-US" sz="900" dirty="0">
+              <a:rPr lang="en-US" sz="900" noProof="1">
                 <a:latin typeface="Arial" panose="020B0604020202020204" pitchFamily="34" charset="0"/>
                 <a:ea typeface="Amazon Ember" panose="020B0603020204020204" pitchFamily="34" charset="0"/>
                 <a:cs typeface="Arial" panose="020B0604020202020204" pitchFamily="34" charset="0"/>
@@ -4094,23 +4099,15 @@
               <a:t>It then creates/adds/updates the score in the leaderboard in the </a:t>
             </a:r>
             <a:r>
-              <a:rPr lang="en-US" sz="900" b="1" dirty="0">
+              <a:rPr lang="en-US" sz="900" b="1" noProof="1">
                 <a:latin typeface="Arial" panose="020B0604020202020204" pitchFamily="34" charset="0"/>
                 <a:ea typeface="Amazon Ember" panose="020B0603020204020204" pitchFamily="34" charset="0"/>
                 <a:cs typeface="Arial" panose="020B0604020202020204" pitchFamily="34" charset="0"/>
               </a:rPr>
-              <a:t>Amazon MemoryDB for </a:t>
-            </a:r>
-            <a:r>
-              <a:rPr lang="en-US" sz="900" b="1" dirty="0" err="1">
-                <a:latin typeface="Arial" panose="020B0604020202020204" pitchFamily="34" charset="0"/>
-                <a:ea typeface="Amazon Ember" panose="020B0603020204020204" pitchFamily="34" charset="0"/>
-                <a:cs typeface="Arial" panose="020B0604020202020204" pitchFamily="34" charset="0"/>
-              </a:rPr>
-              <a:t>Valkey</a:t>
-            </a:r>
-            <a:r>
-              <a:rPr lang="en-US" sz="900" dirty="0">
+              <a:t>Amazon MemoryDB for Valkey</a:t>
+            </a:r>
+            <a:r>
+              <a:rPr lang="en-US" sz="900" noProof="1">
                 <a:latin typeface="Arial" panose="020B0604020202020204" pitchFamily="34" charset="0"/>
                 <a:ea typeface="Amazon Ember" panose="020B0603020204020204" pitchFamily="34" charset="0"/>
                 <a:cs typeface="Arial" panose="020B0604020202020204" pitchFamily="34" charset="0"/>
@@ -4125,7 +4122,7 @@
               </a:spcAft>
             </a:pPr>
             <a:r>
-              <a:rPr lang="en-US" sz="950" dirty="0">
+              <a:rPr lang="en-US" sz="950" noProof="1">
                 <a:latin typeface="Arial" panose="020B0604020202020204" pitchFamily="34" charset="0"/>
                 <a:ea typeface="Amazon Ember" panose="020B0603020204020204" pitchFamily="34" charset="0"/>
                 <a:cs typeface="Arial" panose="020B0604020202020204" pitchFamily="34" charset="0"/>
@@ -4140,7 +4137,7 @@
               </a:spcAft>
             </a:pPr>
             <a:r>
-              <a:rPr lang="en-US" sz="950" dirty="0">
+              <a:rPr lang="en-US" sz="950" noProof="1">
                 <a:latin typeface="Arial" panose="020B0604020202020204" pitchFamily="34" charset="0"/>
                 <a:ea typeface="Amazon Ember" panose="020B0603020204020204" pitchFamily="34" charset="0"/>
                 <a:cs typeface="Arial" panose="020B0604020202020204" pitchFamily="34" charset="0"/>
@@ -4155,7 +4152,7 @@
               </a:spcAft>
             </a:pPr>
             <a:r>
-              <a:rPr lang="en-US" sz="950" dirty="0">
+              <a:rPr lang="en-US" sz="950" noProof="1">
                 <a:latin typeface="Arial" panose="020B0604020202020204" pitchFamily="34" charset="0"/>
                 <a:ea typeface="Amazon Ember" panose="020B0603020204020204" pitchFamily="34" charset="0"/>
                 <a:cs typeface="Arial" panose="020B0604020202020204" pitchFamily="34" charset="0"/>
@@ -4170,7 +4167,7 @@
               </a:spcAft>
             </a:pPr>
             <a:r>
-              <a:rPr lang="en-US" sz="950" dirty="0">
+              <a:rPr lang="en-US" sz="950" noProof="1">
                 <a:latin typeface="Arial" panose="020B0604020202020204" pitchFamily="34" charset="0"/>
                 <a:ea typeface="Amazon Ember" panose="020B0603020204020204" pitchFamily="34" charset="0"/>
                 <a:cs typeface="Arial" panose="020B0604020202020204" pitchFamily="34" charset="0"/>
@@ -4185,7 +4182,7 @@
               </a:spcAft>
             </a:pPr>
             <a:r>
-              <a:rPr lang="en-US" sz="950" dirty="0">
+              <a:rPr lang="en-US" sz="950" noProof="1">
                 <a:latin typeface="Arial" panose="020B0604020202020204" pitchFamily="34" charset="0"/>
                 <a:ea typeface="Amazon Ember" panose="020B0603020204020204" pitchFamily="34" charset="0"/>
                 <a:cs typeface="Arial" panose="020B0604020202020204" pitchFamily="34" charset="0"/>
@@ -4193,7 +4190,7 @@
               <a:t>All player requests for individual scores &amp; leaderboard positions are served by the Player APIs by validating the request, and then querying the MemoryDB </a:t>
             </a:r>
             <a:r>
-              <a:rPr lang="en-US" sz="950" i="1" dirty="0">
+              <a:rPr lang="en-US" sz="950" i="1" noProof="1">
                 <a:latin typeface="Arial" panose="020B0604020202020204" pitchFamily="34" charset="0"/>
                 <a:ea typeface="Amazon Ember" panose="020B0603020204020204" pitchFamily="34" charset="0"/>
                 <a:cs typeface="Arial" panose="020B0604020202020204" pitchFamily="34" charset="0"/>
@@ -4201,7 +4198,7 @@
               <a:t>(for leaderboards, player standings with neighbours)</a:t>
             </a:r>
             <a:r>
-              <a:rPr lang="en-US" sz="950" dirty="0">
+              <a:rPr lang="en-US" sz="950" noProof="1">
                 <a:latin typeface="Arial" panose="020B0604020202020204" pitchFamily="34" charset="0"/>
                 <a:ea typeface="Amazon Ember" panose="020B0603020204020204" pitchFamily="34" charset="0"/>
                 <a:cs typeface="Arial" panose="020B0604020202020204" pitchFamily="34" charset="0"/>
@@ -4209,7 +4206,7 @@
               <a:t>, or the DynamoDB </a:t>
             </a:r>
             <a:r>
-              <a:rPr lang="en-US" sz="950" i="1" dirty="0">
+              <a:rPr lang="en-US" sz="950" i="1" noProof="1">
                 <a:latin typeface="Arial" panose="020B0604020202020204" pitchFamily="34" charset="0"/>
                 <a:ea typeface="Amazon Ember" panose="020B0603020204020204" pitchFamily="34" charset="0"/>
                 <a:cs typeface="Arial" panose="020B0604020202020204" pitchFamily="34" charset="0"/>
@@ -4217,7 +4214,7 @@
               <a:t>(for each and every full player game play reports)</a:t>
             </a:r>
             <a:r>
-              <a:rPr lang="en-US" sz="950" dirty="0">
+              <a:rPr lang="en-US" sz="950" noProof="1">
                 <a:latin typeface="Arial" panose="020B0604020202020204" pitchFamily="34" charset="0"/>
                 <a:ea typeface="Amazon Ember" panose="020B0603020204020204" pitchFamily="34" charset="0"/>
                 <a:cs typeface="Arial" panose="020B0604020202020204" pitchFamily="34" charset="0"/>
@@ -4286,7 +4283,7 @@
               <a:defRPr/>
             </a:pPr>
             <a:r>
-              <a:rPr lang="en-US" sz="900" b="1" dirty="0">
+              <a:rPr lang="en-US" sz="900" b="1" noProof="1">
                 <a:solidFill>
                   <a:schemeClr val="bg1"/>
                 </a:solidFill>
@@ -4357,7 +4354,7 @@
               <a:defRPr/>
             </a:pPr>
             <a:r>
-              <a:rPr lang="en-US" sz="900" b="1" dirty="0">
+              <a:rPr lang="en-US" sz="900" b="1" noProof="1">
                 <a:solidFill>
                   <a:schemeClr val="bg1"/>
                 </a:solidFill>
@@ -4428,7 +4425,7 @@
               <a:defRPr/>
             </a:pPr>
             <a:r>
-              <a:rPr lang="en-US" sz="900" b="1" dirty="0">
+              <a:rPr lang="en-US" sz="900" b="1" noProof="1">
                 <a:solidFill>
                   <a:schemeClr val="bg1"/>
                 </a:solidFill>
@@ -4499,7 +4496,7 @@
               <a:defRPr/>
             </a:pPr>
             <a:r>
-              <a:rPr lang="en-US" sz="900" b="1" dirty="0">
+              <a:rPr lang="en-US" sz="900" b="1" noProof="1">
                 <a:solidFill>
                   <a:schemeClr val="bg1"/>
                 </a:solidFill>
@@ -4570,7 +4567,7 @@
               <a:defRPr/>
             </a:pPr>
             <a:r>
-              <a:rPr lang="en-US" sz="900" b="1" dirty="0">
+              <a:rPr lang="en-US" sz="900" b="1" noProof="1">
                 <a:solidFill>
                   <a:schemeClr val="bg1"/>
                 </a:solidFill>
@@ -4641,7 +4638,7 @@
               <a:defRPr/>
             </a:pPr>
             <a:r>
-              <a:rPr lang="en-US" sz="900" b="1" dirty="0">
+              <a:rPr lang="en-US" sz="900" b="1" noProof="1">
                 <a:solidFill>
                   <a:schemeClr val="bg1"/>
                 </a:solidFill>
@@ -4712,7 +4709,7 @@
               <a:defRPr/>
             </a:pPr>
             <a:r>
-              <a:rPr lang="en-US" sz="900" b="1" dirty="0">
+              <a:rPr lang="en-US" sz="900" b="1" noProof="1">
                 <a:solidFill>
                   <a:schemeClr val="bg1"/>
                 </a:solidFill>
@@ -4781,7 +4778,7 @@
               <a:defRPr/>
             </a:pPr>
             <a:r>
-              <a:rPr lang="en-US" sz="1200" dirty="0">
+              <a:rPr lang="en-US" sz="1200" noProof="1">
                 <a:solidFill>
                   <a:schemeClr val="tx1"/>
                 </a:solidFill>
@@ -4852,7 +4849,7 @@
               <a:defRPr/>
             </a:pPr>
             <a:r>
-              <a:rPr lang="en-US" sz="900" b="1" dirty="0">
+              <a:rPr lang="en-US" sz="900" b="1" noProof="1">
                 <a:solidFill>
                   <a:schemeClr val="bg1"/>
                 </a:solidFill>
@@ -4923,7 +4920,7 @@
               <a:defRPr/>
             </a:pPr>
             <a:r>
-              <a:rPr lang="en-US" sz="900" b="1" dirty="0">
+              <a:rPr lang="en-US" sz="900" b="1" noProof="1">
                 <a:solidFill>
                   <a:schemeClr val="bg1"/>
                 </a:solidFill>
@@ -4994,7 +4991,7 @@
               <a:defRPr/>
             </a:pPr>
             <a:r>
-              <a:rPr lang="en-US" sz="900" b="1" dirty="0">
+              <a:rPr lang="en-US" sz="900" b="1" noProof="1">
                 <a:solidFill>
                   <a:schemeClr val="bg1"/>
                 </a:solidFill>
@@ -5070,7 +5067,7 @@
           <a:lstStyle/>
           <a:p>
             <a:r>
-              <a:rPr lang="en-US" sz="2400" b="1" dirty="0">
+              <a:rPr lang="en-US" sz="2400" b="1" noProof="1">
                 <a:latin typeface="Arial" panose="020B0604020202020204" pitchFamily="34" charset="0"/>
                 <a:ea typeface="Amazon Ember" panose="020B0603020204020204" pitchFamily="34" charset="0"/>
                 <a:cs typeface="Arial" panose="020B0604020202020204" pitchFamily="34" charset="0"/>
@@ -5080,7 +5077,7 @@
           </a:p>
           <a:p>
             <a:r>
-              <a:rPr lang="en-US" sz="1200" b="1" dirty="0">
+              <a:rPr lang="en-US" sz="1200" b="1" noProof="1">
                 <a:latin typeface="Arial" panose="020B0604020202020204" pitchFamily="34" charset="0"/>
                 <a:cs typeface="Arial" panose="020B0604020202020204" pitchFamily="34" charset="0"/>
               </a:rPr>
@@ -5089,13 +5086,13 @@
           </a:p>
           <a:p>
             <a:r>
-              <a:rPr lang="en-US" sz="1100" i="1" dirty="0">
+              <a:rPr lang="en-US" sz="1100" i="1" noProof="1">
                 <a:latin typeface="Arial" panose="020B0604020202020204" pitchFamily="34" charset="0"/>
                 <a:cs typeface="Arial" panose="020B0604020202020204" pitchFamily="34" charset="0"/>
               </a:rPr>
               <a:t> Designed as a standalone component that is easy to integrate in your game backend. It supports multiple per-game, per-player, and multiplayer session statistics, variety of score types, different ranking strategies, event leaderboards with expiry, and long-running operations.</a:t>
             </a:r>
-            <a:endParaRPr lang="en-US" sz="700" b="1" i="1" dirty="0">
+            <a:endParaRPr lang="en-US" sz="700" b="1" i="1" noProof="1">
               <a:latin typeface="Arial" panose="020B0604020202020204" pitchFamily="34" charset="0"/>
               <a:cs typeface="Arial" panose="020B0604020202020204" pitchFamily="34" charset="0"/>
             </a:endParaRPr>
@@ -5131,7 +5128,7 @@
           <a:lstStyle/>
           <a:p>
             <a:r>
-              <a:rPr lang="en-US" sz="1200" b="1" dirty="0">
+              <a:rPr lang="en-US" sz="1200" b="1" noProof="1">
                 <a:solidFill>
                   <a:schemeClr val="accent2"/>
                 </a:solidFill>
@@ -5310,7 +5307,7 @@
               <a:defRPr/>
             </a:pPr>
             <a:r>
-              <a:rPr lang="en-US" altLang="x-none" sz="933" b="0" i="1" dirty="0">
+              <a:rPr lang="en-US" sz="933" b="0" i="1" noProof="1">
                 <a:solidFill>
                   <a:srgbClr val="7F7F7F"/>
                 </a:solidFill>
@@ -5324,7 +5321,7 @@
           <a:p>
             <a:pPr eaLnBrk="1" hangingPunct="1"/>
             <a:r>
-              <a:rPr lang="en-US" altLang="x-none" sz="933" b="0" i="0" dirty="0">
+              <a:rPr lang="en-US" sz="933" b="0" i="0" noProof="1">
                 <a:solidFill>
                   <a:srgbClr val="7F7F7F"/>
                 </a:solidFill>
@@ -5374,7 +5371,7 @@
               </a:spcAft>
             </a:pPr>
             <a:r>
-              <a:rPr lang="en-US" altLang="en-US" sz="1400" b="1" dirty="0">
+              <a:rPr lang="en-US" sz="1400" b="1" noProof="1">
                 <a:solidFill>
                   <a:srgbClr val="FF9900"/>
                 </a:solidFill>
@@ -5632,7 +5629,7 @@
           <a:p>
             <a:pPr algn="ctr" eaLnBrk="1" hangingPunct="1"/>
             <a:r>
-              <a:rPr lang="en-US" altLang="en-US" sz="900" dirty="0">
+              <a:rPr lang="en-US" sz="900" noProof="1">
                 <a:solidFill>
                   <a:schemeClr val="tx2">
                     <a:lumMod val="75000"/>
@@ -5856,7 +5853,7 @@
           <a:p>
             <a:pPr algn="ctr" eaLnBrk="1" hangingPunct="1"/>
             <a:r>
-              <a:rPr lang="en-US" altLang="en-US" sz="900" dirty="0">
+              <a:rPr lang="en-US" sz="900" noProof="1">
                 <a:latin typeface="Arial" panose="020B0604020202020204" pitchFamily="34" charset="0"/>
                 <a:ea typeface="Amazon Ember" panose="020B0603020204020204" pitchFamily="34" charset="0"/>
                 <a:cs typeface="Arial" panose="020B0604020202020204" pitchFamily="34" charset="0"/>
@@ -6053,7 +6050,7 @@
           <a:p>
             <a:pPr algn="ctr" eaLnBrk="1" hangingPunct="1"/>
             <a:r>
-              <a:rPr lang="en-US" altLang="en-US" sz="900" dirty="0">
+              <a:rPr lang="en-US" sz="900" noProof="1">
                 <a:latin typeface="Arial" panose="020B0604020202020204" pitchFamily="34" charset="0"/>
                 <a:ea typeface="Amazon Ember" panose="020B0603020204020204" pitchFamily="34" charset="0"/>
                 <a:cs typeface="Arial" panose="020B0604020202020204" pitchFamily="34" charset="0"/>
@@ -6272,7 +6269,7 @@
           <a:p>
             <a:pPr algn="ctr" eaLnBrk="1" hangingPunct="1"/>
             <a:r>
-              <a:rPr lang="en-US" altLang="en-US" sz="900" dirty="0">
+              <a:rPr lang="en-US" sz="900" noProof="1">
                 <a:latin typeface="Arial" panose="020B0604020202020204" pitchFamily="34" charset="0"/>
                 <a:ea typeface="Amazon Ember" panose="020B0603020204020204" pitchFamily="34" charset="0"/>
                 <a:cs typeface="Arial" panose="020B0604020202020204" pitchFamily="34" charset="0"/>
@@ -6491,7 +6488,7 @@
           <a:p>
             <a:pPr algn="ctr" eaLnBrk="1" hangingPunct="1"/>
             <a:r>
-              <a:rPr lang="en-US" altLang="en-US" sz="900" dirty="0">
+              <a:rPr lang="en-US" sz="900" noProof="1">
                 <a:latin typeface="Arial" panose="020B0604020202020204" pitchFamily="34" charset="0"/>
                 <a:ea typeface="Amazon Ember" panose="020B0603020204020204" pitchFamily="34" charset="0"/>
                 <a:cs typeface="Arial" panose="020B0604020202020204" pitchFamily="34" charset="0"/>
@@ -6627,7 +6624,7 @@
                 </a:spcAft>
                 <a:defRPr/>
               </a:pPr>
-              <a:endParaRPr lang="en-US" dirty="0"/>
+              <a:endParaRPr lang="en-US" noProof="1"/>
             </a:p>
           </p:txBody>
         </p:sp>
@@ -6923,7 +6920,7 @@
           <a:p>
             <a:pPr algn="ctr" eaLnBrk="1" hangingPunct="1"/>
             <a:r>
-              <a:rPr lang="en-US" altLang="en-US" sz="900" dirty="0" err="1">
+              <a:rPr lang="en-US" sz="900" noProof="1">
                 <a:solidFill>
                   <a:schemeClr val="tx2">
                     <a:lumMod val="75000"/>
@@ -6936,17 +6933,6 @@
               </a:rPr>
               <a:t>playerAuthorizer</a:t>
             </a:r>
-            <a:endParaRPr lang="en-US" altLang="en-US" sz="900" dirty="0">
-              <a:solidFill>
-                <a:schemeClr val="tx2">
-                  <a:lumMod val="75000"/>
-                  <a:lumOff val="25000"/>
-                </a:schemeClr>
-              </a:solidFill>
-              <a:latin typeface="Aptos" panose="020B0004020202020204" pitchFamily="34" charset="0"/>
-              <a:ea typeface="Amazon Ember" panose="020B0603020204020204" pitchFamily="34" charset="0"/>
-              <a:cs typeface="Arial" panose="020B0604020202020204" pitchFamily="34" charset="0"/>
-            </a:endParaRPr>
           </a:p>
         </p:txBody>
       </p:sp>
@@ -7101,7 +7087,7 @@
           <a:p>
             <a:pPr algn="ctr" eaLnBrk="1" hangingPunct="1"/>
             <a:r>
-              <a:rPr lang="en-US" altLang="en-US" sz="900" dirty="0" err="1">
+              <a:rPr lang="en-US" sz="900" noProof="1">
                 <a:solidFill>
                   <a:schemeClr val="tx2">
                     <a:lumMod val="75000"/>
@@ -7114,17 +7100,6 @@
               </a:rPr>
               <a:t>backendAuthorizer</a:t>
             </a:r>
-            <a:endParaRPr lang="en-US" altLang="en-US" sz="900" dirty="0">
-              <a:solidFill>
-                <a:schemeClr val="tx2">
-                  <a:lumMod val="75000"/>
-                  <a:lumOff val="25000"/>
-                </a:schemeClr>
-              </a:solidFill>
-              <a:latin typeface="Aptos" panose="020B0004020202020204" pitchFamily="34" charset="0"/>
-              <a:ea typeface="Amazon Ember" panose="020B0603020204020204" pitchFamily="34" charset="0"/>
-              <a:cs typeface="Arial" panose="020B0604020202020204" pitchFamily="34" charset="0"/>
-            </a:endParaRPr>
           </a:p>
         </p:txBody>
       </p:sp>
@@ -7326,7 +7301,7 @@
           <a:p>
             <a:pPr algn="ctr" eaLnBrk="1" hangingPunct="1"/>
             <a:r>
-              <a:rPr lang="en-US" altLang="en-US" sz="900" dirty="0" err="1">
+              <a:rPr lang="en-US" sz="900" noProof="1">
                 <a:solidFill>
                   <a:schemeClr val="tx2">
                     <a:lumMod val="75000"/>
@@ -7339,17 +7314,6 @@
               </a:rPr>
               <a:t>studioAPIKey</a:t>
             </a:r>
-            <a:endParaRPr lang="en-US" altLang="en-US" sz="900" dirty="0">
-              <a:solidFill>
-                <a:schemeClr val="tx2">
-                  <a:lumMod val="75000"/>
-                  <a:lumOff val="25000"/>
-                </a:schemeClr>
-              </a:solidFill>
-              <a:latin typeface="Aptos" panose="020B0004020202020204" pitchFamily="34" charset="0"/>
-              <a:ea typeface="Amazon Ember" panose="020B0603020204020204" pitchFamily="34" charset="0"/>
-              <a:cs typeface="Arial" panose="020B0604020202020204" pitchFamily="34" charset="0"/>
-            </a:endParaRPr>
           </a:p>
         </p:txBody>
       </p:sp>
@@ -7504,7 +7468,7 @@
           <a:p>
             <a:pPr algn="ctr" eaLnBrk="1" hangingPunct="1"/>
             <a:r>
-              <a:rPr lang="en-US" altLang="en-US" sz="900" dirty="0">
+              <a:rPr lang="en-US" sz="900" noProof="1">
                 <a:solidFill>
                   <a:schemeClr val="tx2">
                     <a:lumMod val="75000"/>
@@ -7625,7 +7589,7 @@
               <a:defRPr/>
             </a:pPr>
             <a:r>
-              <a:rPr lang="en-US" sz="900" dirty="0">
+              <a:rPr lang="en-US" sz="900" noProof="1">
                 <a:solidFill>
                   <a:schemeClr val="tx2">
                     <a:lumMod val="75000"/>
@@ -7849,7 +7813,7 @@
           <a:p>
             <a:pPr algn="ctr" eaLnBrk="1" hangingPunct="1"/>
             <a:r>
-              <a:rPr lang="en-US" altLang="en-US" sz="900" dirty="0">
+              <a:rPr lang="en-US" sz="900" noProof="1">
                 <a:latin typeface="Arial" panose="020B0604020202020204" pitchFamily="34" charset="0"/>
                 <a:ea typeface="Amazon Ember" panose="020B0603020204020204" pitchFamily="34" charset="0"/>
                 <a:cs typeface="Arial" panose="020B0604020202020204" pitchFamily="34" charset="0"/>
@@ -8068,7 +8032,7 @@
           <a:p>
             <a:pPr algn="ctr" eaLnBrk="1" hangingPunct="1"/>
             <a:r>
-              <a:rPr lang="en-US" altLang="en-US" sz="900" dirty="0">
+              <a:rPr lang="en-US" sz="900" noProof="1">
                 <a:latin typeface="Arial" panose="020B0604020202020204" pitchFamily="34" charset="0"/>
                 <a:ea typeface="Amazon Ember" panose="020B0603020204020204" pitchFamily="34" charset="0"/>
                 <a:cs typeface="Arial" panose="020B0604020202020204" pitchFamily="34" charset="0"/>
@@ -8287,7 +8251,7 @@
           <a:p>
             <a:pPr algn="ctr" eaLnBrk="1" hangingPunct="1"/>
             <a:r>
-              <a:rPr lang="en-US" altLang="en-US" sz="900" dirty="0">
+              <a:rPr lang="en-US" sz="900" noProof="1">
                 <a:latin typeface="Arial" panose="020B0604020202020204" pitchFamily="34" charset="0"/>
                 <a:ea typeface="Amazon Ember" panose="020B0603020204020204" pitchFamily="34" charset="0"/>
                 <a:cs typeface="Arial" panose="020B0604020202020204" pitchFamily="34" charset="0"/>
@@ -8484,7 +8448,7 @@
           <a:p>
             <a:pPr algn="ctr" eaLnBrk="1" hangingPunct="1"/>
             <a:r>
-              <a:rPr lang="en-US" altLang="en-US" sz="900" i="1" dirty="0">
+              <a:rPr lang="en-US" sz="900" i="1" noProof="1">
                 <a:solidFill>
                   <a:schemeClr val="tx2">
                     <a:lumMod val="75000"/>
@@ -8498,7 +8462,7 @@
               <a:t>Table 1:</a:t>
             </a:r>
             <a:br>
-              <a:rPr lang="en-US" altLang="en-US" sz="900" dirty="0">
+              <a:rPr lang="en-US" sz="900" noProof="1">
                 <a:solidFill>
                   <a:schemeClr val="tx2">
                     <a:lumMod val="75000"/>
@@ -8511,7 +8475,7 @@
               </a:rPr>
             </a:br>
             <a:r>
-              <a:rPr lang="en-US" altLang="en-US" sz="900" dirty="0">
+              <a:rPr lang="en-US" sz="900" noProof="1">
                 <a:solidFill>
                   <a:schemeClr val="tx2">
                     <a:lumMod val="75000"/>
@@ -8714,7 +8678,7 @@
           <a:p>
             <a:pPr algn="ctr" eaLnBrk="1" hangingPunct="1"/>
             <a:r>
-              <a:rPr lang="en-US" altLang="en-US" sz="900" i="1" dirty="0">
+              <a:rPr lang="en-US" sz="900" i="1" noProof="1">
                 <a:solidFill>
                   <a:schemeClr val="tx2">
                     <a:lumMod val="75000"/>
@@ -8728,7 +8692,7 @@
               <a:t>Table 2:</a:t>
             </a:r>
             <a:br>
-              <a:rPr lang="en-US" altLang="en-US" sz="900" dirty="0">
+              <a:rPr lang="en-US" sz="900" noProof="1">
                 <a:solidFill>
                   <a:schemeClr val="tx2">
                     <a:lumMod val="75000"/>
@@ -8741,7 +8705,7 @@
               </a:rPr>
             </a:br>
             <a:r>
-              <a:rPr lang="en-US" altLang="en-US" sz="900" dirty="0">
+              <a:rPr lang="en-US" sz="900" noProof="1">
                 <a:solidFill>
                   <a:schemeClr val="tx2">
                     <a:lumMod val="75000"/>
@@ -8814,7 +8778,7 @@
               </a:spcAft>
               <a:defRPr/>
             </a:pPr>
-            <a:endParaRPr lang="en-US" sz="900" dirty="0">
+            <a:endParaRPr lang="en-US" sz="900" noProof="1">
               <a:solidFill>
                 <a:schemeClr val="tx1"/>
               </a:solidFill>
@@ -8916,7 +8880,7 @@
               </a:spcAft>
               <a:defRPr/>
             </a:pPr>
-            <a:endParaRPr lang="en-US" sz="1200" dirty="0">
+            <a:endParaRPr lang="en-US" sz="1200" noProof="1">
               <a:solidFill>
                 <a:schemeClr val="tx1"/>
               </a:solidFill>
@@ -9077,7 +9041,7 @@
           <a:p>
             <a:pPr algn="ctr" eaLnBrk="1" hangingPunct="1"/>
             <a:r>
-              <a:rPr lang="en-US" altLang="en-US" sz="900" dirty="0" err="1">
+              <a:rPr lang="en-US" sz="900" noProof="1">
                 <a:solidFill>
                   <a:schemeClr val="tx2">
                     <a:lumMod val="75000"/>
@@ -9088,24 +9052,10 @@
                 <a:ea typeface="Amazon Ember" panose="020B0603020204020204" pitchFamily="34" charset="0"/>
                 <a:cs typeface="Arial" panose="020B0604020202020204" pitchFamily="34" charset="0"/>
               </a:rPr>
-              <a:t>developerRegistration</a:t>
-            </a:r>
-            <a:r>
-              <a:rPr lang="en-US" altLang="en-US" sz="900" dirty="0">
-                <a:solidFill>
-                  <a:schemeClr val="tx2">
-                    <a:lumMod val="75000"/>
-                    <a:lumOff val="25000"/>
-                  </a:schemeClr>
-                </a:solidFill>
-                <a:latin typeface="Aptos" panose="020B0004020202020204" pitchFamily="34" charset="0"/>
-                <a:ea typeface="Amazon Ember" panose="020B0603020204020204" pitchFamily="34" charset="0"/>
-                <a:cs typeface="Arial" panose="020B0604020202020204" pitchFamily="34" charset="0"/>
-              </a:rPr>
-              <a:t> (CRU)</a:t>
+              <a:t>developerRegistration (CRU)</a:t>
             </a:r>
             <a:br>
-              <a:rPr lang="en-US" altLang="en-US" sz="900" dirty="0">
+              <a:rPr lang="en-US" sz="900" noProof="1">
                 <a:solidFill>
                   <a:schemeClr val="tx2">
                     <a:lumMod val="75000"/>
@@ -9118,7 +9068,7 @@
               </a:rPr>
             </a:br>
             <a:r>
-              <a:rPr lang="en-US" altLang="en-US" sz="900" dirty="0" err="1">
+              <a:rPr lang="en-US" sz="900" noProof="1">
                 <a:solidFill>
                   <a:schemeClr val="tx2">
                     <a:lumMod val="75000"/>
@@ -9129,24 +9079,10 @@
                 <a:ea typeface="Amazon Ember" panose="020B0603020204020204" pitchFamily="34" charset="0"/>
                 <a:cs typeface="Arial" panose="020B0604020202020204" pitchFamily="34" charset="0"/>
               </a:rPr>
-              <a:t>leaderboardsConfig</a:t>
-            </a:r>
-            <a:r>
-              <a:rPr lang="en-US" altLang="en-US" sz="900" dirty="0">
-                <a:solidFill>
-                  <a:schemeClr val="tx2">
-                    <a:lumMod val="75000"/>
-                    <a:lumOff val="25000"/>
-                  </a:schemeClr>
-                </a:solidFill>
-                <a:latin typeface="Aptos" panose="020B0004020202020204" pitchFamily="34" charset="0"/>
-                <a:ea typeface="Amazon Ember" panose="020B0603020204020204" pitchFamily="34" charset="0"/>
-                <a:cs typeface="Arial" panose="020B0604020202020204" pitchFamily="34" charset="0"/>
-              </a:rPr>
-              <a:t> (CRUD)</a:t>
+              <a:t>leaderboardsConfig (CRUD)</a:t>
             </a:r>
             <a:br>
-              <a:rPr lang="en-US" altLang="en-US" sz="900" dirty="0">
+              <a:rPr lang="en-US" sz="900" noProof="1">
                 <a:solidFill>
                   <a:schemeClr val="tx2">
                     <a:lumMod val="75000"/>
@@ -9159,7 +9095,7 @@
               </a:rPr>
             </a:br>
             <a:r>
-              <a:rPr lang="en-US" altLang="en-US" sz="900" dirty="0" err="1">
+              <a:rPr lang="en-US" sz="900" noProof="1">
                 <a:solidFill>
                   <a:schemeClr val="tx2">
                     <a:lumMod val="75000"/>
@@ -9173,7 +9109,7 @@
               <a:t>resetLeaderboard</a:t>
             </a:r>
             <a:br>
-              <a:rPr lang="en-US" altLang="en-US" sz="900" dirty="0">
+              <a:rPr lang="en-US" sz="900" noProof="1">
                 <a:solidFill>
                   <a:schemeClr val="tx2">
                     <a:lumMod val="75000"/>
@@ -9186,7 +9122,7 @@
               </a:rPr>
             </a:br>
             <a:r>
-              <a:rPr lang="en-US" altLang="en-US" sz="900" dirty="0" err="1">
+              <a:rPr lang="en-US" sz="900" noProof="1">
                 <a:solidFill>
                   <a:schemeClr val="tx2">
                     <a:lumMod val="75000"/>
@@ -9200,7 +9136,7 @@
               <a:t>rebuildLeaderboard</a:t>
             </a:r>
             <a:br>
-              <a:rPr lang="en-US" altLang="en-US" sz="900" dirty="0">
+              <a:rPr lang="en-US" sz="900" noProof="1">
                 <a:solidFill>
                   <a:schemeClr val="tx2">
                     <a:lumMod val="75000"/>
@@ -9213,7 +9149,7 @@
               </a:rPr>
             </a:br>
             <a:r>
-              <a:rPr lang="en-US" altLang="en-US" sz="900" dirty="0" err="1">
+              <a:rPr lang="en-US" sz="900" noProof="1">
                 <a:solidFill>
                   <a:schemeClr val="tx2">
                     <a:lumMod val="75000"/>
@@ -9226,17 +9162,6 @@
               </a:rPr>
               <a:t>batchStoreStatsAndScores</a:t>
             </a:r>
-            <a:endParaRPr lang="en-US" altLang="en-US" sz="900" dirty="0">
-              <a:solidFill>
-                <a:schemeClr val="tx2">
-                  <a:lumMod val="75000"/>
-                  <a:lumOff val="25000"/>
-                </a:schemeClr>
-              </a:solidFill>
-              <a:latin typeface="Aptos" panose="020B0004020202020204" pitchFamily="34" charset="0"/>
-              <a:ea typeface="Amazon Ember" panose="020B0603020204020204" pitchFamily="34" charset="0"/>
-              <a:cs typeface="Arial" panose="020B0604020202020204" pitchFamily="34" charset="0"/>
-            </a:endParaRPr>
           </a:p>
         </p:txBody>
       </p:sp>
@@ -9487,7 +9412,7 @@
           <a:p>
             <a:pPr algn="ctr" eaLnBrk="1" hangingPunct="1"/>
             <a:r>
-              <a:rPr lang="en-US" altLang="en-US" sz="900" dirty="0">
+              <a:rPr lang="en-US" sz="900" noProof="1">
                 <a:solidFill>
                   <a:schemeClr val="tx2">
                     <a:lumMod val="75000"/>
@@ -9654,7 +9579,7 @@
           <a:p>
             <a:pPr algn="ctr" eaLnBrk="1" hangingPunct="1"/>
             <a:r>
-              <a:rPr lang="en-US" altLang="en-US" sz="900" dirty="0">
+              <a:rPr lang="en-US" sz="900" noProof="1">
                 <a:solidFill>
                   <a:schemeClr val="tx2">
                     <a:lumMod val="75000"/>
@@ -9821,7 +9746,7 @@
           <a:p>
             <a:pPr algn="ctr" eaLnBrk="1" hangingPunct="1"/>
             <a:r>
-              <a:rPr lang="en-US" altLang="en-US" sz="900" dirty="0" err="1">
+              <a:rPr lang="en-US" sz="900" noProof="1">
                 <a:solidFill>
                   <a:schemeClr val="tx2">
                     <a:lumMod val="75000"/>
@@ -9835,7 +9760,7 @@
               <a:t>storePlayerStatsAndScores</a:t>
             </a:r>
             <a:br>
-              <a:rPr lang="en-US" altLang="en-US" sz="900" dirty="0">
+              <a:rPr lang="en-US" sz="900" noProof="1">
                 <a:solidFill>
                   <a:schemeClr val="tx2">
                     <a:lumMod val="75000"/>
@@ -9848,7 +9773,7 @@
               </a:rPr>
             </a:br>
             <a:r>
-              <a:rPr lang="en-US" altLang="en-US" sz="900" dirty="0" err="1">
+              <a:rPr lang="en-US" sz="900" noProof="1">
                 <a:solidFill>
                   <a:schemeClr val="tx2">
                     <a:lumMod val="75000"/>
@@ -9862,7 +9787,7 @@
               <a:t>getPlayerStatsAndScores</a:t>
             </a:r>
             <a:br>
-              <a:rPr lang="en-US" altLang="en-US" sz="900" dirty="0">
+              <a:rPr lang="en-US" sz="900" noProof="1">
                 <a:solidFill>
                   <a:schemeClr val="tx2">
                     <a:lumMod val="75000"/>
@@ -9875,7 +9800,7 @@
               </a:rPr>
             </a:br>
             <a:r>
-              <a:rPr lang="en-US" altLang="en-US" sz="900" dirty="0" err="1">
+              <a:rPr lang="en-US" sz="900" noProof="1">
                 <a:solidFill>
                   <a:schemeClr val="tx2">
                     <a:lumMod val="75000"/>
@@ -9889,7 +9814,7 @@
               <a:t>getPlayerLBStanding</a:t>
             </a:r>
             <a:br>
-              <a:rPr lang="en-US" altLang="en-US" sz="900" dirty="0">
+              <a:rPr lang="en-US" sz="900" noProof="1">
                 <a:solidFill>
                   <a:schemeClr val="tx2">
                     <a:lumMod val="75000"/>
@@ -9902,7 +9827,7 @@
               </a:rPr>
             </a:br>
             <a:r>
-              <a:rPr lang="en-US" altLang="en-US" sz="900" dirty="0" err="1">
+              <a:rPr lang="en-US" sz="900" noProof="1">
                 <a:solidFill>
                   <a:schemeClr val="tx2">
                     <a:lumMod val="75000"/>
@@ -9915,17 +9840,6 @@
               </a:rPr>
               <a:t>getLeaderboardScores</a:t>
             </a:r>
-            <a:endParaRPr lang="en-US" altLang="en-US" sz="900" dirty="0">
-              <a:solidFill>
-                <a:schemeClr val="tx2">
-                  <a:lumMod val="75000"/>
-                  <a:lumOff val="25000"/>
-                </a:schemeClr>
-              </a:solidFill>
-              <a:latin typeface="Aptos" panose="020B0004020202020204" pitchFamily="34" charset="0"/>
-              <a:ea typeface="Amazon Ember" panose="020B0603020204020204" pitchFamily="34" charset="0"/>
-              <a:cs typeface="Arial" panose="020B0604020202020204" pitchFamily="34" charset="0"/>
-            </a:endParaRPr>
           </a:p>
         </p:txBody>
       </p:sp>
@@ -10174,7 +10088,7 @@
           <a:p>
             <a:pPr algn="ctr" eaLnBrk="1" hangingPunct="1"/>
             <a:r>
-              <a:rPr lang="en-US" altLang="en-US" sz="900" dirty="0">
+              <a:rPr lang="en-US" sz="900" noProof="1">
                 <a:latin typeface="Arial" panose="020B0604020202020204" pitchFamily="34" charset="0"/>
                 <a:ea typeface="Amazon Ember" panose="020B0603020204020204" pitchFamily="34" charset="0"/>
                 <a:cs typeface="Arial" panose="020B0604020202020204" pitchFamily="34" charset="0"/>
@@ -10182,37 +10096,29 @@
               <a:t>Amazon MemoryDB</a:t>
             </a:r>
             <a:br>
-              <a:rPr lang="en-US" altLang="en-US" sz="900" dirty="0">
+              <a:rPr lang="en-US" sz="900" noProof="1">
                 <a:latin typeface="Arial" panose="020B0604020202020204" pitchFamily="34" charset="0"/>
                 <a:ea typeface="Amazon Ember" panose="020B0603020204020204" pitchFamily="34" charset="0"/>
                 <a:cs typeface="Arial" panose="020B0604020202020204" pitchFamily="34" charset="0"/>
               </a:rPr>
             </a:br>
             <a:r>
-              <a:rPr lang="en-US" altLang="en-US" sz="900" dirty="0">
+              <a:rPr lang="en-US" sz="900" noProof="1">
                 <a:latin typeface="Arial" panose="020B0604020202020204" pitchFamily="34" charset="0"/>
                 <a:ea typeface="Amazon Ember" panose="020B0603020204020204" pitchFamily="34" charset="0"/>
                 <a:cs typeface="Arial" panose="020B0604020202020204" pitchFamily="34" charset="0"/>
               </a:rPr>
-              <a:t>for </a:t>
-            </a:r>
-            <a:r>
-              <a:rPr lang="en-US" altLang="en-US" sz="900" dirty="0" err="1">
-                <a:latin typeface="Arial" panose="020B0604020202020204" pitchFamily="34" charset="0"/>
-                <a:ea typeface="Amazon Ember" panose="020B0603020204020204" pitchFamily="34" charset="0"/>
-                <a:cs typeface="Arial" panose="020B0604020202020204" pitchFamily="34" charset="0"/>
-              </a:rPr>
-              <a:t>Valkey</a:t>
+              <a:t>for Valkey</a:t>
             </a:r>
             <a:br>
-              <a:rPr lang="en-US" altLang="en-US" sz="900" dirty="0">
+              <a:rPr lang="en-US" sz="900" noProof="1">
                 <a:latin typeface="Arial" panose="020B0604020202020204" pitchFamily="34" charset="0"/>
                 <a:ea typeface="Amazon Ember" panose="020B0603020204020204" pitchFamily="34" charset="0"/>
                 <a:cs typeface="Arial" panose="020B0604020202020204" pitchFamily="34" charset="0"/>
               </a:rPr>
             </a:br>
             <a:r>
-              <a:rPr lang="en-US" altLang="en-US" sz="900" dirty="0">
+              <a:rPr lang="en-US" sz="900" noProof="1">
                 <a:solidFill>
                   <a:schemeClr val="tx2">
                     <a:lumMod val="75000"/>
@@ -10334,7 +10240,7 @@
               </a:spcAft>
               <a:defRPr/>
             </a:pPr>
-            <a:endParaRPr lang="en-US" dirty="0"/>
+            <a:endParaRPr lang="en-US" noProof="1"/>
           </a:p>
         </p:txBody>
       </p:sp>
@@ -10446,7 +10352,7 @@
               </a:spcAft>
               <a:defRPr/>
             </a:pPr>
-            <a:endParaRPr lang="en-US" dirty="0"/>
+            <a:endParaRPr lang="en-US" noProof="1"/>
           </a:p>
         </p:txBody>
       </p:sp>
@@ -10533,7 +10439,7 @@
               <a:defRPr/>
             </a:pPr>
             <a:r>
-              <a:rPr lang="en-US" sz="900" dirty="0">
+              <a:rPr lang="en-US" sz="900" noProof="1">
                 <a:solidFill>
                   <a:schemeClr val="tx1"/>
                 </a:solidFill>
@@ -10601,7 +10507,7 @@
               </a:spcAft>
               <a:defRPr/>
             </a:pPr>
-            <a:endParaRPr lang="en-US" sz="900" dirty="0">
+            <a:endParaRPr lang="en-US" sz="900" noProof="1">
               <a:ln w="0"/>
               <a:solidFill>
                 <a:schemeClr val="tx1"/>
@@ -10650,7 +10556,7 @@
               <a:defRPr/>
             </a:pPr>
             <a:r>
-              <a:rPr lang="en-US" sz="900" dirty="0">
+              <a:rPr lang="en-US" sz="900" noProof="1">
                 <a:solidFill>
                   <a:schemeClr val="tx1"/>
                 </a:solidFill>
@@ -10906,7 +10812,7 @@
           <a:p>
             <a:pPr algn="ctr" eaLnBrk="1" hangingPunct="1"/>
             <a:r>
-              <a:rPr lang="en-US" altLang="en-US" sz="900" dirty="0">
+              <a:rPr lang="en-US" sz="900" noProof="1">
                 <a:latin typeface="Arial" panose="020B0604020202020204" pitchFamily="34" charset="0"/>
                 <a:ea typeface="Amazon Ember" panose="020B0603020204020204" pitchFamily="34" charset="0"/>
                 <a:cs typeface="Arial" panose="020B0604020202020204" pitchFamily="34" charset="0"/>
@@ -11125,7 +11031,7 @@
           <a:p>
             <a:pPr algn="ctr" eaLnBrk="1" hangingPunct="1"/>
             <a:r>
-              <a:rPr lang="en-US" altLang="en-US" sz="900" dirty="0">
+              <a:rPr lang="en-US" sz="900" noProof="1">
                 <a:latin typeface="Arial" panose="020B0604020202020204" pitchFamily="34" charset="0"/>
                 <a:ea typeface="Amazon Ember" panose="020B0603020204020204" pitchFamily="34" charset="0"/>
                 <a:cs typeface="Arial" panose="020B0604020202020204" pitchFamily="34" charset="0"/>
@@ -11322,7 +11228,7 @@
           <a:p>
             <a:pPr eaLnBrk="1" hangingPunct="1"/>
             <a:r>
-              <a:rPr lang="en-US" altLang="en-US" sz="900" dirty="0">
+              <a:rPr lang="en-US" sz="900" noProof="1">
                 <a:latin typeface="Arial" panose="020B0604020202020204" pitchFamily="34" charset="0"/>
                 <a:ea typeface="Amazon Ember" panose="020B0603020204020204" pitchFamily="34" charset="0"/>
                 <a:cs typeface="Arial" panose="020B0604020202020204" pitchFamily="34" charset="0"/>
@@ -11519,7 +11425,7 @@
           <a:p>
             <a:pPr eaLnBrk="1" hangingPunct="1"/>
             <a:r>
-              <a:rPr lang="en-US" altLang="en-US" sz="900" dirty="0">
+              <a:rPr lang="en-US" sz="900" noProof="1">
                 <a:latin typeface="Arial" panose="020B0604020202020204" pitchFamily="34" charset="0"/>
                 <a:ea typeface="Amazon Ember" panose="020B0603020204020204" pitchFamily="34" charset="0"/>
                 <a:cs typeface="Arial" panose="020B0604020202020204" pitchFamily="34" charset="0"/>
@@ -11716,7 +11622,7 @@
           <a:p>
             <a:pPr eaLnBrk="1" hangingPunct="1"/>
             <a:r>
-              <a:rPr lang="en-US" altLang="en-US" sz="900" dirty="0">
+              <a:rPr lang="en-US" sz="900" noProof="1">
                 <a:latin typeface="Arial" panose="020B0604020202020204" pitchFamily="34" charset="0"/>
                 <a:ea typeface="Amazon Ember" panose="020B0603020204020204" pitchFamily="34" charset="0"/>
                 <a:cs typeface="Arial" panose="020B0604020202020204" pitchFamily="34" charset="0"/>
@@ -11785,7 +11691,7 @@
               <a:defRPr/>
             </a:pPr>
             <a:r>
-              <a:rPr lang="en-US" sz="900" b="1" dirty="0">
+              <a:rPr lang="en-US" sz="900" b="1" noProof="1">
                 <a:solidFill>
                   <a:schemeClr val="bg1"/>
                 </a:solidFill>
@@ -11856,7 +11762,7 @@
               <a:defRPr/>
             </a:pPr>
             <a:r>
-              <a:rPr lang="en-US" sz="900" b="1" dirty="0">
+              <a:rPr lang="en-US" sz="900" b="1" noProof="1">
                 <a:solidFill>
                   <a:schemeClr val="bg1"/>
                 </a:solidFill>
@@ -11927,7 +11833,7 @@
               <a:defRPr/>
             </a:pPr>
             <a:r>
-              <a:rPr lang="en-US" sz="900" b="1" dirty="0">
+              <a:rPr lang="en-US" sz="900" b="1" noProof="1">
                 <a:solidFill>
                   <a:schemeClr val="bg1"/>
                 </a:solidFill>
@@ -11998,7 +11904,7 @@
               <a:defRPr/>
             </a:pPr>
             <a:r>
-              <a:rPr lang="en-US" sz="900" b="1" dirty="0">
+              <a:rPr lang="en-US" sz="900" b="1" noProof="1">
                 <a:solidFill>
                   <a:schemeClr val="bg1"/>
                 </a:solidFill>
@@ -12069,7 +11975,7 @@
               <a:defRPr/>
             </a:pPr>
             <a:r>
-              <a:rPr lang="en-US" sz="900" b="1" dirty="0">
+              <a:rPr lang="en-US" sz="900" b="1" noProof="1">
                 <a:solidFill>
                   <a:schemeClr val="bg1"/>
                 </a:solidFill>
@@ -12140,7 +12046,7 @@
               <a:defRPr/>
             </a:pPr>
             <a:r>
-              <a:rPr lang="en-US" sz="900" b="1" dirty="0">
+              <a:rPr lang="en-US" sz="900" b="1" noProof="1">
                 <a:solidFill>
                   <a:schemeClr val="bg1"/>
                 </a:solidFill>
@@ -12211,7 +12117,7 @@
               <a:defRPr/>
             </a:pPr>
             <a:r>
-              <a:rPr lang="en-US" sz="900" b="1" dirty="0">
+              <a:rPr lang="en-US" sz="900" b="1" noProof="1">
                 <a:solidFill>
                   <a:schemeClr val="bg1"/>
                 </a:solidFill>
@@ -12282,7 +12188,7 @@
               <a:defRPr/>
             </a:pPr>
             <a:r>
-              <a:rPr lang="en-US" sz="900" b="1" dirty="0">
+              <a:rPr lang="en-US" sz="900" b="1" noProof="1">
                 <a:solidFill>
                   <a:schemeClr val="bg1"/>
                 </a:solidFill>
@@ -12353,7 +12259,7 @@
               <a:defRPr/>
             </a:pPr>
             <a:r>
-              <a:rPr lang="en-US" sz="900" b="1" dirty="0">
+              <a:rPr lang="en-US" sz="900" b="1" noProof="1">
                 <a:solidFill>
                   <a:schemeClr val="bg1"/>
                 </a:solidFill>
@@ -12424,7 +12330,7 @@
               <a:defRPr/>
             </a:pPr>
             <a:r>
-              <a:rPr lang="en-US" sz="900" b="1" dirty="0">
+              <a:rPr lang="en-US" sz="900" b="1" noProof="1">
                 <a:solidFill>
                   <a:schemeClr val="bg1"/>
                 </a:solidFill>
@@ -12495,7 +12401,7 @@
               <a:defRPr/>
             </a:pPr>
             <a:r>
-              <a:rPr lang="en-US" sz="900" b="1" dirty="0">
+              <a:rPr lang="en-US" sz="900" b="1" noProof="1">
                 <a:solidFill>
                   <a:schemeClr val="bg1"/>
                 </a:solidFill>
@@ -12566,7 +12472,7 @@
               <a:defRPr/>
             </a:pPr>
             <a:r>
-              <a:rPr lang="en-US" sz="900" b="1" dirty="0">
+              <a:rPr lang="en-US" sz="900" b="1" noProof="1">
                 <a:solidFill>
                   <a:schemeClr val="bg1"/>
                 </a:solidFill>
@@ -12693,7 +12599,7 @@
               </a:spcAft>
               <a:defRPr/>
             </a:pPr>
-            <a:endParaRPr lang="en-US" sz="900" dirty="0">
+            <a:endParaRPr lang="en-US" sz="900" noProof="1">
               <a:solidFill>
                 <a:schemeClr val="tx2">
                   <a:lumMod val="75000"/>
@@ -12756,7 +12662,7 @@
           <a:p>
             <a:pPr algn="ctr"/>
             <a:r>
-              <a:rPr lang="en-US" altLang="en-US" sz="900" dirty="0">
+              <a:rPr lang="en-US" sz="900" noProof="1">
                 <a:solidFill>
                   <a:schemeClr val="tx2">
                     <a:lumMod val="75000"/>
@@ -12768,7 +12674,7 @@
               </a:rPr>
               <a:t>Game Backend</a:t>
             </a:r>
-            <a:endParaRPr lang="en-US" sz="900" dirty="0">
+            <a:endParaRPr lang="en-US" sz="900" noProof="1">
               <a:solidFill>
                 <a:schemeClr val="tx2">
                   <a:lumMod val="75000"/>
@@ -12967,7 +12873,7 @@
           <a:p>
             <a:pPr algn="ctr" eaLnBrk="1" hangingPunct="1"/>
             <a:r>
-              <a:rPr lang="en-US" altLang="en-US" sz="900" dirty="0">
+              <a:rPr lang="en-US" sz="900" noProof="1">
                 <a:solidFill>
                   <a:schemeClr val="tx2">
                     <a:lumMod val="75000"/>
@@ -12980,7 +12886,7 @@
               <a:t>Admin user</a:t>
             </a:r>
             <a:br>
-              <a:rPr lang="en-US" altLang="en-US" sz="900" dirty="0">
+              <a:rPr lang="en-US" sz="900" noProof="1">
                 <a:solidFill>
                   <a:schemeClr val="tx2">
                     <a:lumMod val="75000"/>
@@ -12992,7 +12898,7 @@
               </a:rPr>
             </a:br>
             <a:r>
-              <a:rPr lang="en-US" altLang="en-US" sz="900" dirty="0">
+              <a:rPr lang="en-US" sz="900" noProof="1">
                 <a:solidFill>
                   <a:schemeClr val="tx2">
                     <a:lumMod val="75000"/>

</xml_diff>